<commit_message>
Sacar tecnologías del modelo (dataset final → interfaz)
Las tecnologías se quitan como features del modelo predictivo: su premium
era proxy del contexto (backend/dólar) y como entrada generaban ruido
(ej. "Go" en un rol que no lo usa). Se mantienen en el dataset y en el
EDA (pestaña Tecnologías, H3) como análisis descriptivo.

- predictor_cli / evaluacion_modelos / _usd: features sin tecnologías (9 cols)
- estimador ES/EN y CLI: se quita el selector de tecnologías
- R² 0.30 → 0.27 (RF empata con polinómica); se mantiene RF en producción
- PPT/DOCX y gráficos regenerados en consecuencia

Co-Authored-By: Claude Opus 4.8 <noreply@anthropic.com>
</commit_message>
<xml_diff>
--- a/presentacion/defensa_oral.pptx
+++ b/presentacion/defensa_oral.pptx
@@ -5181,7 +5181,7 @@
                 </a:solidFill>
                 <a:latin typeface="Arial"/>
               </a:rPr>
-              <a:t>Cinco técnicas, una ganadora</a:t>
+              <a:t>Cinco técnicas comparadas</a:t>
             </a:r>
           </a:p>
         </p:txBody>
@@ -5348,7 +5348,7 @@
                 </a:solidFill>
                 <a:latin typeface="Calibri"/>
               </a:rPr>
-              <a:t>—  Lineal múltiple: 0.24</a:t>
+              <a:t>—  Lineal múltiple: 0.22</a:t>
             </a:r>
           </a:p>
           <a:p>
@@ -5367,7 +5367,7 @@
                 </a:solidFill>
                 <a:latin typeface="Calibri"/>
               </a:rPr>
-              <a:t>—  Polinómica: 0.29</a:t>
+              <a:t>—  Árbol: 0.20</a:t>
             </a:r>
           </a:p>
           <a:p>
@@ -5386,7 +5386,7 @@
                 </a:solidFill>
                 <a:latin typeface="Calibri"/>
               </a:rPr>
-              <a:t>—  Árbol: 0.22</a:t>
+              <a:t>—  Polinómica: 0.28</a:t>
             </a:r>
           </a:p>
           <a:p>
@@ -5405,7 +5405,7 @@
                 </a:solidFill>
                 <a:latin typeface="Calibri"/>
               </a:rPr>
-              <a:t>—  Random Forest: 0.30</a:t>
+              <a:t>—  Random Forest: 0.27 (elegido)</a:t>
             </a:r>
           </a:p>
         </p:txBody>
@@ -5685,7 +5685,7 @@
                 </a:solidFill>
                 <a:latin typeface="Arial"/>
               </a:rPr>
-              <a:t>Mejor desempeño</a:t>
+              <a:t>A la par del mejor R²</a:t>
             </a:r>
           </a:p>
           <a:p>
@@ -5704,7 +5704,7 @@
                 </a:solidFill>
                 <a:latin typeface="Calibri"/>
               </a:rPr>
-              <a:t>mayor R² en test (0.30) y menor error (MAE $1,42M).</a:t>
+              <a:t>empata con la polinómica en test (R²≈0.27); se elige por lo demás.</a:t>
             </a:r>
           </a:p>
         </p:txBody>
@@ -7559,7 +7559,7 @@
                 </a:solidFill>
                 <a:latin typeface="Arial"/>
               </a:rPr>
-              <a:t>Alta cardinalidad de roles/techs</a:t>
+              <a:t>Ruido de las tecnologías</a:t>
             </a:r>
           </a:p>
           <a:p>
@@ -7578,7 +7578,7 @@
                 </a:solidFill>
                 <a:latin typeface="Calibri"/>
               </a:rPr>
-              <a:t>agrupación + multi-hot para señal estable.</a:t>
+              <a:t>sacadas del modelo (su premium era proxy del contexto); roles agrupados en top-15.</a:t>
             </a:r>
           </a:p>
         </p:txBody>
@@ -14533,7 +14533,7 @@
                 </a:solidFill>
                 <a:latin typeface="Arial"/>
               </a:rPr>
-              <a:t>Multi-hot de tecnologías (top 20)</a:t>
+              <a:t>Tecnologías: FUERA del modelo</a:t>
             </a:r>
           </a:p>
           <a:p>
@@ -14552,7 +14552,7 @@
                 </a:solidFill>
                 <a:latin typeface="Calibri"/>
               </a:rPr>
-              <a:t>texto libre «python, sql» → 20 binarias → captura el premium por stack específico.</a:t>
+              <a:t>su premium era proxy del contexto (backend/dólar) y como feature generaban ruido; se analizan en el EDA.</a:t>
             </a:r>
           </a:p>
         </p:txBody>

</xml_diff>

<commit_message>
Fuentes crudas versionadas en parquet + README desarrollado + hipótesis sin inflación
- data/raw: gemelo .parquet lossless de cada CSV crudo (140 MB → 11 MB el de
  Stack Overflow); fuentes_raw.py convierte y provee leer_csv/existe con
  fallback automático. El pipeline completo corre con un clon del repo sin
  ningún CSV (verificado: dataset resultante idéntico).
- README: desarrollado en base al documento de defensa (hipótesis H1–H6,
  fuentes, metodología, modelos, apps, reproducibilidad). Se quita la
  inflación de la hipótesis.
- Defensa (PPT 21 slides + DOCX): se elimina la hipótesis de inflación (H5)
  y la slide/sección de evolución del poder de compra; se renumeran H6→H5 y
  H7→H6; resultados pasan a brechas/región; nota de reproducibilidad parquet.
  Generadores versionados en presentacion/.

Co-Authored-By: Claude Opus 4.8 <noreply@anthropic.com>
</commit_message>
<xml_diff>
--- a/presentacion/defensa_oral.pptx
+++ b/presentacion/defensa_oral.pptx
@@ -26,7 +26,6 @@
     <p:sldId id="274" r:id="rId25"/>
     <p:sldId id="275" r:id="rId26"/>
     <p:sldId id="276" r:id="rId27"/>
-    <p:sldId id="277" r:id="rId28"/>
   </p:sldIdLst>
   <p:sldSz cx="12191695" cy="6858000" type="screen4x3"/>
   <p:notesSz cx="6858000" cy="9144000"/>
@@ -7730,14 +7729,14 @@
                 </a:solidFill>
                 <a:latin typeface="Arial"/>
               </a:rPr>
-              <a:t>Brechas, inflación y región</a:t>
+              <a:t>Brechas salariales y región</a:t>
             </a:r>
           </a:p>
         </p:txBody>
       </p:sp>
       <p:pic>
         <p:nvPicPr>
-          <p:cNvPr id="5" name="Picture 4" descr="eda_06_poder_adquisitivo.png"/>
+          <p:cNvPr id="5" name="Picture 4" descr="eda_05_geografia.png"/>
           <p:cNvPicPr>
             <a:picLocks noChangeAspect="1"/>
           </p:cNvPicPr>
@@ -7751,8 +7750,8 @@
         </p:blipFill>
         <p:spPr>
           <a:xfrm>
-            <a:off x="457200" y="2237966"/>
-            <a:ext cx="6766560" cy="3022147"/>
+            <a:off x="1057444" y="1737360"/>
+            <a:ext cx="5566071" cy="4023360"/>
           </a:xfrm>
           <a:prstGeom prst="rect">
             <a:avLst/>
@@ -7840,7 +7839,7 @@
                 </a:solidFill>
                 <a:latin typeface="Arial"/>
               </a:rPr>
-              <a:t>−62%</a:t>
+              <a:t>3×</a:t>
             </a:r>
           </a:p>
           <a:p>
@@ -7859,7 +7858,7 @@
                 </a:solidFill>
                 <a:latin typeface="Calibri"/>
               </a:rPr>
-              <a:t>brecha promedio entre el sueldo nominal y el real</a:t>
+              <a:t>brecha junior → senior: la experiencia manda</a:t>
             </a:r>
           </a:p>
           <a:p>
@@ -7897,7 +7896,7 @@
                 </a:solidFill>
                 <a:latin typeface="Calibri"/>
               </a:rPr>
-              <a:t>jr→sr casi 3×  ·  liderazgo +0,19 (la mayor)</a:t>
+              <a:t>liderazgo +0,19 (la mayor)  ·  remoto +43% en USD</a:t>
             </a:r>
           </a:p>
           <a:p>
@@ -7954,7 +7953,7 @@
                 </a:solidFill>
                 <a:latin typeface="Calibri"/>
               </a:rPr>
-              <a:t>Dolarización (H6): no dio más estabilidad.</a:t>
+              <a:t>Dolarización (H5): no dio más estabilidad.</a:t>
             </a:r>
           </a:p>
         </p:txBody>
@@ -8773,7 +8772,7 @@
                 </a:solidFill>
                 <a:latin typeface="Arial"/>
               </a:rPr>
-              <a:t>RESULTADOS · IMPACTO DE LA INFLACIÓN</a:t>
+              <a:t>RESULTADOS · COMPARATIVA INTERNACIONAL</a:t>
             </a:r>
           </a:p>
         </p:txBody>
@@ -8815,14 +8814,14 @@
                 </a:solidFill>
                 <a:latin typeface="Arial"/>
               </a:rPr>
-              <a:t>Evolución del poder de compra en el tiempo</a:t>
+              <a:t>Argentina vs el mundo</a:t>
             </a:r>
           </a:p>
         </p:txBody>
       </p:sp>
       <p:pic>
         <p:nvPicPr>
-          <p:cNvPr id="5" name="Picture 4" descr="evolucion_indices.png"/>
+          <p:cNvPr id="5" name="Picture 4" descr="comparacion_mundo.png"/>
           <p:cNvPicPr>
             <a:picLocks noChangeAspect="1"/>
           </p:cNvPicPr>
@@ -8836,8 +8835,8 @@
         </p:blipFill>
         <p:spPr>
           <a:xfrm>
-            <a:off x="365760" y="2124356"/>
-            <a:ext cx="7680960" cy="3523686"/>
+            <a:off x="365760" y="2007196"/>
+            <a:ext cx="7955279" cy="3849447"/>
           </a:xfrm>
           <a:prstGeom prst="rect">
             <a:avLst/>
@@ -8852,8 +8851,8 @@
         </p:nvSpPr>
         <p:spPr>
           <a:xfrm>
-            <a:off x="8229600" y="1828800"/>
-            <a:ext cx="3474720" cy="4114800"/>
+            <a:off x="8412480" y="1828800"/>
+            <a:ext cx="3291840" cy="4114800"/>
           </a:xfrm>
           <a:prstGeom prst="roundRect">
             <a:avLst/>
@@ -8896,8 +8895,8 @@
         </p:nvSpPr>
         <p:spPr>
           <a:xfrm>
-            <a:off x="8458200" y="2057400"/>
-            <a:ext cx="3063240" cy="3749039"/>
+            <a:off x="8641080" y="2057400"/>
+            <a:ext cx="2880360" cy="3749039"/>
           </a:xfrm>
           <a:prstGeom prst="rect">
             <a:avLst/>
@@ -8925,16 +8924,16 @@
                 </a:solidFill>
                 <a:latin typeface="Arial"/>
               </a:rPr>
-              <a:t>QUÉ MUESTRA</a:t>
-            </a:r>
-          </a:p>
-          <a:p>
-            <a:pPr algn="l">
-              <a:spcBef>
-                <a:spcPts val="0"/>
-              </a:spcBef>
-              <a:spcAft>
-                <a:spcPts val="1000"/>
+              <a:t>STACK OVERFLOW</a:t>
+            </a:r>
+          </a:p>
+          <a:p>
+            <a:pPr algn="l">
+              <a:spcBef>
+                <a:spcPts val="0"/>
+              </a:spcBef>
+              <a:spcAft>
+                <a:spcPts val="900"/>
               </a:spcAft>
             </a:pPr>
             <a:r>
@@ -8944,7 +8943,7 @@
                 </a:solidFill>
                 <a:latin typeface="Calibri"/>
               </a:rPr>
-              <a:t>El salario en distintas «varas», base 2022.2 = 100:</a:t>
+              <a:t>—  Argentina USD 3.333/mes</a:t>
             </a:r>
           </a:p>
           <a:p>
@@ -8957,13 +8956,13 @@
               </a:spcAft>
             </a:pPr>
             <a:r>
-              <a:rPr sz="1200" b="0" i="0">
+              <a:rPr sz="1250" b="0" i="0">
                 <a:solidFill>
                   <a:srgbClr val="FFFFFF"/>
                 </a:solidFill>
                 <a:latin typeface="Calibri"/>
               </a:rPr>
-              <a:t>—  En pesos reales quedó casi estancado</a:t>
+              <a:t>—  Arriba de Brasil, Ucrania e India</a:t>
             </a:r>
           </a:p>
           <a:p>
@@ -8976,51 +8975,32 @@
               </a:spcAft>
             </a:pPr>
             <a:r>
-              <a:rPr sz="1200" b="0" i="0">
+              <a:rPr sz="1250" b="0" i="0">
                 <a:solidFill>
                   <a:srgbClr val="FFFFFF"/>
                 </a:solidFill>
                 <a:latin typeface="Calibri"/>
               </a:rPr>
-              <a:t>—  En USD del momento casi se triplicó (el dólar se atrasó)</a:t>
-            </a:r>
-          </a:p>
-          <a:p>
-            <a:pPr algn="l">
-              <a:spcBef>
-                <a:spcPts val="0"/>
-              </a:spcBef>
-              <a:spcAft>
-                <a:spcPts val="900"/>
-              </a:spcAft>
-            </a:pPr>
-            <a:r>
-              <a:rPr sz="1200" b="0" i="0">
-                <a:solidFill>
-                  <a:srgbClr val="FFFFFF"/>
+              <a:t>—  Abajo de Europa y EE.UU. (12.500)</a:t>
+            </a:r>
+          </a:p>
+          <a:p>
+            <a:pPr algn="l">
+              <a:spcBef>
+                <a:spcPts val="0"/>
+              </a:spcBef>
+              <a:spcAft>
+                <a:spcPts val="600"/>
+              </a:spcAft>
+            </a:pPr>
+            <a:r>
+              <a:rPr sz="1200" b="0" i="1">
+                <a:solidFill>
+                  <a:srgbClr val="E6FF00"/>
                 </a:solidFill>
                 <a:latin typeface="Calibri"/>
               </a:rPr>
-              <a:t>—  Pico en 2024.1 tras la devaluación</a:t>
-            </a:r>
-          </a:p>
-          <a:p>
-            <a:pPr algn="l">
-              <a:spcBef>
-                <a:spcPts val="0"/>
-              </a:spcBef>
-              <a:spcAft>
-                <a:spcPts val="900"/>
-              </a:spcAft>
-            </a:pPr>
-            <a:r>
-              <a:rPr sz="1200" b="0" i="0">
-                <a:solidFill>
-                  <a:srgbClr val="FFFFFF"/>
-                </a:solidFill>
-                <a:latin typeface="Calibri"/>
-              </a:rPr>
-              <a:t>—  vs RIPTE: los devs se despegaron del salario formal</a:t>
+              <a:t>Sysarmy mide USD 2.264: más conservador. Stack Overflow capta perfiles más internacionales / senior.</a:t>
             </a:r>
           </a:p>
         </p:txBody>
@@ -9058,164 +9038,6 @@
             <a:avLst/>
           </a:prstGeom>
           <a:solidFill>
-            <a:srgbClr val="FFFFFF"/>
-          </a:solidFill>
-          <a:ln>
-            <a:noFill/>
-          </a:ln>
-          <a:effectLst/>
-        </p:spPr>
-        <p:style>
-          <a:lnRef idx="1">
-            <a:schemeClr val="accent1"/>
-          </a:lnRef>
-          <a:fillRef idx="3">
-            <a:schemeClr val="accent1"/>
-          </a:fillRef>
-          <a:effectRef idx="2">
-            <a:schemeClr val="accent1"/>
-          </a:effectRef>
-          <a:fontRef idx="minor">
-            <a:schemeClr val="lt1"/>
-          </a:fontRef>
-        </p:style>
-        <p:txBody>
-          <a:bodyPr rtlCol="0" anchor="ctr"/>
-          <a:lstStyle/>
-          <a:p>
-            <a:pPr algn="ctr"/>
-          </a:p>
-        </p:txBody>
-      </p:sp>
-      <p:sp>
-        <p:nvSpPr>
-          <p:cNvPr id="3" name="TextBox 2"/>
-          <p:cNvSpPr txBox="1"/>
-          <p:nvPr/>
-        </p:nvSpPr>
-        <p:spPr>
-          <a:xfrm>
-            <a:off x="548640" y="384048"/>
-            <a:ext cx="10058400" cy="457200"/>
-          </a:xfrm>
-          <a:prstGeom prst="rect">
-            <a:avLst/>
-          </a:prstGeom>
-          <a:noFill/>
-        </p:spPr>
-        <p:txBody>
-          <a:bodyPr wrap="square" lIns="45720" rIns="45720" tIns="18288" bIns="18288">
-            <a:spAutoFit/>
-          </a:bodyPr>
-          <a:lstStyle/>
-          <a:p>
-            <a:pPr>
-              <a:spcAft>
-                <a:spcPts val="0"/>
-              </a:spcAft>
-            </a:pPr>
-            <a:r>
-              <a:rPr sz="1300" b="1">
-                <a:solidFill>
-                  <a:srgbClr val="0A0A0A"/>
-                </a:solidFill>
-                <a:latin typeface="Arial"/>
-              </a:rPr>
-              <a:t>06  ·  </a:t>
-            </a:r>
-            <a:r>
-              <a:rPr sz="1300" b="1">
-                <a:solidFill>
-                  <a:srgbClr val="8C8C8C"/>
-                </a:solidFill>
-                <a:latin typeface="Arial"/>
-              </a:rPr>
-              <a:t>RESULTADOS · COMPARATIVA INTERNACIONAL</a:t>
-            </a:r>
-          </a:p>
-        </p:txBody>
-      </p:sp>
-      <p:sp>
-        <p:nvSpPr>
-          <p:cNvPr id="4" name="TextBox 3"/>
-          <p:cNvSpPr txBox="1"/>
-          <p:nvPr/>
-        </p:nvSpPr>
-        <p:spPr>
-          <a:xfrm>
-            <a:off x="548640" y="868680"/>
-            <a:ext cx="11064240" cy="914400"/>
-          </a:xfrm>
-          <a:prstGeom prst="rect">
-            <a:avLst/>
-          </a:prstGeom>
-          <a:noFill/>
-        </p:spPr>
-        <p:txBody>
-          <a:bodyPr wrap="square" lIns="45720" rIns="45720" tIns="18288" bIns="18288">
-            <a:spAutoFit/>
-          </a:bodyPr>
-          <a:lstStyle/>
-          <a:p>
-            <a:pPr algn="l">
-              <a:spcBef>
-                <a:spcPts val="0"/>
-              </a:spcBef>
-              <a:spcAft>
-                <a:spcPts val="0"/>
-              </a:spcAft>
-            </a:pPr>
-            <a:r>
-              <a:rPr sz="3400" b="1" i="0">
-                <a:solidFill>
-                  <a:srgbClr val="0A0A0A"/>
-                </a:solidFill>
-                <a:latin typeface="Arial"/>
-              </a:rPr>
-              <a:t>Argentina vs el mundo</a:t>
-            </a:r>
-          </a:p>
-        </p:txBody>
-      </p:sp>
-      <p:pic>
-        <p:nvPicPr>
-          <p:cNvPr id="5" name="Picture 4" descr="comparacion_mundo.png"/>
-          <p:cNvPicPr>
-            <a:picLocks noChangeAspect="1"/>
-          </p:cNvPicPr>
-          <p:nvPr/>
-        </p:nvPicPr>
-        <p:blipFill>
-          <a:blip r:embed="rId2"/>
-          <a:stretch>
-            <a:fillRect/>
-          </a:stretch>
-        </p:blipFill>
-        <p:spPr>
-          <a:xfrm>
-            <a:off x="365760" y="2007196"/>
-            <a:ext cx="7955279" cy="3849447"/>
-          </a:xfrm>
-          <a:prstGeom prst="rect">
-            <a:avLst/>
-          </a:prstGeom>
-        </p:spPr>
-      </p:pic>
-      <p:sp>
-        <p:nvSpPr>
-          <p:cNvPr id="6" name="Rounded Rectangle 5"/>
-          <p:cNvSpPr/>
-          <p:nvPr/>
-        </p:nvSpPr>
-        <p:spPr>
-          <a:xfrm>
-            <a:off x="8412480" y="1828800"/>
-            <a:ext cx="3291840" cy="4114800"/>
-          </a:xfrm>
-          <a:prstGeom prst="roundRect">
-            <a:avLst/>
-          </a:prstGeom>
-          <a:solidFill>
             <a:srgbClr val="0A0A0A"/>
           </a:solidFill>
           <a:ln>
@@ -9247,14 +9069,14 @@
       </p:sp>
       <p:sp>
         <p:nvSpPr>
-          <p:cNvPr id="7" name="TextBox 6"/>
+          <p:cNvPr id="3" name="TextBox 2"/>
           <p:cNvSpPr txBox="1"/>
           <p:nvPr/>
         </p:nvSpPr>
         <p:spPr>
           <a:xfrm>
-            <a:off x="8641080" y="2057400"/>
-            <a:ext cx="2880360" cy="3749039"/>
+            <a:off x="548640" y="384048"/>
+            <a:ext cx="10058400" cy="457200"/>
           </a:xfrm>
           <a:prstGeom prst="rect">
             <a:avLst/>
@@ -9267,174 +9089,42 @@
           </a:bodyPr>
           <a:lstStyle/>
           <a:p>
-            <a:pPr algn="l">
-              <a:spcBef>
-                <a:spcPts val="0"/>
-              </a:spcBef>
-              <a:spcAft>
-                <a:spcPts val="800"/>
-              </a:spcAft>
-            </a:pPr>
-            <a:r>
-              <a:rPr sz="1300" b="1" i="0">
+            <a:pPr>
+              <a:spcAft>
+                <a:spcPts val="0"/>
+              </a:spcAft>
+            </a:pPr>
+            <a:r>
+              <a:rPr sz="1300" b="1">
                 <a:solidFill>
                   <a:srgbClr val="E6FF00"/>
                 </a:solidFill>
                 <a:latin typeface="Arial"/>
               </a:rPr>
-              <a:t>STACK OVERFLOW</a:t>
-            </a:r>
-          </a:p>
-          <a:p>
-            <a:pPr algn="l">
-              <a:spcBef>
-                <a:spcPts val="0"/>
-              </a:spcBef>
-              <a:spcAft>
-                <a:spcPts val="900"/>
-              </a:spcAft>
-            </a:pPr>
-            <a:r>
-              <a:rPr sz="1250" b="0" i="0">
-                <a:solidFill>
-                  <a:srgbClr val="FFFFFF"/>
-                </a:solidFill>
-                <a:latin typeface="Calibri"/>
-              </a:rPr>
-              <a:t>—  Argentina USD 3.333/mes</a:t>
-            </a:r>
-          </a:p>
-          <a:p>
-            <a:pPr algn="l">
-              <a:spcBef>
-                <a:spcPts val="0"/>
-              </a:spcBef>
-              <a:spcAft>
-                <a:spcPts val="900"/>
-              </a:spcAft>
-            </a:pPr>
-            <a:r>
-              <a:rPr sz="1250" b="0" i="0">
-                <a:solidFill>
-                  <a:srgbClr val="FFFFFF"/>
-                </a:solidFill>
-                <a:latin typeface="Calibri"/>
-              </a:rPr>
-              <a:t>—  Arriba de Brasil, Ucrania e India</a:t>
-            </a:r>
-          </a:p>
-          <a:p>
-            <a:pPr algn="l">
-              <a:spcBef>
-                <a:spcPts val="0"/>
-              </a:spcBef>
-              <a:spcAft>
-                <a:spcPts val="900"/>
-              </a:spcAft>
-            </a:pPr>
-            <a:r>
-              <a:rPr sz="1250" b="0" i="0">
-                <a:solidFill>
-                  <a:srgbClr val="FFFFFF"/>
-                </a:solidFill>
-                <a:latin typeface="Calibri"/>
-              </a:rPr>
-              <a:t>—  Abajo de Europa y EE.UU. (12.500)</a:t>
-            </a:r>
-          </a:p>
-          <a:p>
-            <a:pPr algn="l">
-              <a:spcBef>
-                <a:spcPts val="0"/>
-              </a:spcBef>
-              <a:spcAft>
-                <a:spcPts val="600"/>
-              </a:spcAft>
-            </a:pPr>
-            <a:r>
-              <a:rPr sz="1200" b="0" i="1">
-                <a:solidFill>
-                  <a:srgbClr val="E6FF00"/>
-                </a:solidFill>
-                <a:latin typeface="Calibri"/>
-              </a:rPr>
-              <a:t>Sysarmy mide USD 2.264: más conservador. Stack Overflow capta perfiles más internacionales / senior.</a:t>
-            </a:r>
-          </a:p>
-        </p:txBody>
-      </p:sp>
-    </p:spTree>
-  </p:cSld>
-  <p:clrMapOvr>
-    <a:masterClrMapping/>
-  </p:clrMapOvr>
-</p:sld>
-</file>
-
-<file path=ppt/slides/slide22.xml><?xml version="1.0" encoding="utf-8"?>
-<p:sld xmlns:a="http://schemas.openxmlformats.org/drawingml/2006/main" xmlns:p="http://schemas.openxmlformats.org/presentationml/2006/main" xmlns:r="http://schemas.openxmlformats.org/officeDocument/2006/relationships">
-  <p:cSld>
-    <p:spTree>
-      <p:nvGrpSpPr>
-        <p:cNvPr id="1" name=""/>
-        <p:cNvGrpSpPr/>
-        <p:nvPr/>
-      </p:nvGrpSpPr>
-      <p:grpSpPr/>
-      <p:sp>
-        <p:nvSpPr>
-          <p:cNvPr id="2" name="Rectangle 1"/>
-          <p:cNvSpPr/>
-          <p:nvPr/>
-        </p:nvSpPr>
-        <p:spPr>
-          <a:xfrm>
-            <a:off x="0" y="0"/>
-            <a:ext cx="12191695" cy="6858000"/>
-          </a:xfrm>
-          <a:prstGeom prst="rect">
-            <a:avLst/>
-          </a:prstGeom>
-          <a:solidFill>
-            <a:srgbClr val="0A0A0A"/>
-          </a:solidFill>
-          <a:ln>
-            <a:noFill/>
-          </a:ln>
-          <a:effectLst/>
-        </p:spPr>
-        <p:style>
-          <a:lnRef idx="1">
-            <a:schemeClr val="accent1"/>
-          </a:lnRef>
-          <a:fillRef idx="3">
-            <a:schemeClr val="accent1"/>
-          </a:fillRef>
-          <a:effectRef idx="2">
-            <a:schemeClr val="accent1"/>
-          </a:effectRef>
-          <a:fontRef idx="minor">
-            <a:schemeClr val="lt1"/>
-          </a:fontRef>
-        </p:style>
-        <p:txBody>
-          <a:bodyPr rtlCol="0" anchor="ctr"/>
-          <a:lstStyle/>
-          <a:p>
-            <a:pPr algn="ctr"/>
-          </a:p>
-        </p:txBody>
-      </p:sp>
-      <p:sp>
-        <p:nvSpPr>
-          <p:cNvPr id="3" name="TextBox 2"/>
+              <a:t>07  ·  </a:t>
+            </a:r>
+            <a:r>
+              <a:rPr sz="1300" b="1">
+                <a:solidFill>
+                  <a:srgbClr val="8C8C8C"/>
+                </a:solidFill>
+                <a:latin typeface="Arial"/>
+              </a:rPr>
+              <a:t>CONCLUSIONES</a:t>
+            </a:r>
+          </a:p>
+        </p:txBody>
+      </p:sp>
+      <p:sp>
+        <p:nvSpPr>
+          <p:cNvPr id="4" name="TextBox 3"/>
           <p:cNvSpPr txBox="1"/>
           <p:nvPr/>
         </p:nvSpPr>
         <p:spPr>
           <a:xfrm>
-            <a:off x="548640" y="384048"/>
-            <a:ext cx="10058400" cy="457200"/>
+            <a:off x="548640" y="868680"/>
+            <a:ext cx="11064240" cy="914400"/>
           </a:xfrm>
           <a:prstGeom prst="rect">
             <a:avLst/>
@@ -9447,42 +9137,36 @@
           </a:bodyPr>
           <a:lstStyle/>
           <a:p>
-            <a:pPr>
-              <a:spcAft>
-                <a:spcPts val="0"/>
-              </a:spcAft>
-            </a:pPr>
-            <a:r>
-              <a:rPr sz="1300" b="1">
-                <a:solidFill>
-                  <a:srgbClr val="E6FF00"/>
+            <a:pPr algn="l">
+              <a:spcBef>
+                <a:spcPts val="0"/>
+              </a:spcBef>
+              <a:spcAft>
+                <a:spcPts val="0"/>
+              </a:spcAft>
+            </a:pPr>
+            <a:r>
+              <a:rPr sz="3400" b="1" i="0">
+                <a:solidFill>
+                  <a:srgbClr val="FFFFFF"/>
                 </a:solidFill>
                 <a:latin typeface="Arial"/>
               </a:rPr>
-              <a:t>07  ·  </a:t>
-            </a:r>
-            <a:r>
-              <a:rPr sz="1300" b="1">
-                <a:solidFill>
-                  <a:srgbClr val="8C8C8C"/>
-                </a:solidFill>
-                <a:latin typeface="Arial"/>
-              </a:rPr>
-              <a:t>CONCLUSIONES</a:t>
-            </a:r>
-          </a:p>
-        </p:txBody>
-      </p:sp>
-      <p:sp>
-        <p:nvSpPr>
-          <p:cNvPr id="4" name="TextBox 3"/>
+              <a:t>Hallazgos y valor estratégico</a:t>
+            </a:r>
+          </a:p>
+        </p:txBody>
+      </p:sp>
+      <p:sp>
+        <p:nvSpPr>
+          <p:cNvPr id="5" name="TextBox 4"/>
           <p:cNvSpPr txBox="1"/>
           <p:nvPr/>
         </p:nvSpPr>
         <p:spPr>
           <a:xfrm>
-            <a:off x="548640" y="868680"/>
-            <a:ext cx="11064240" cy="914400"/>
+            <a:off x="548640" y="1783080"/>
+            <a:ext cx="5943600" cy="4480560"/>
           </a:xfrm>
           <a:prstGeom prst="rect">
             <a:avLst/>
@@ -9500,59 +9184,36 @@
                 <a:spcPts val="0"/>
               </a:spcBef>
               <a:spcAft>
-                <a:spcPts val="0"/>
-              </a:spcAft>
-            </a:pPr>
-            <a:r>
-              <a:rPr sz="3400" b="1" i="0">
+                <a:spcPts val="800"/>
+              </a:spcAft>
+            </a:pPr>
+            <a:r>
+              <a:rPr sz="1500" b="1" i="0">
+                <a:solidFill>
+                  <a:srgbClr val="E6FF00"/>
+                </a:solidFill>
+                <a:latin typeface="Arial"/>
+              </a:rPr>
+              <a:t>Principales hallazgos</a:t>
+            </a:r>
+          </a:p>
+          <a:p>
+            <a:pPr algn="l">
+              <a:spcBef>
+                <a:spcPts val="0"/>
+              </a:spcBef>
+              <a:spcAft>
+                <a:spcPts val="1000"/>
+              </a:spcAft>
+            </a:pPr>
+            <a:r>
+              <a:rPr sz="1350" b="0" i="0">
                 <a:solidFill>
                   <a:srgbClr val="FFFFFF"/>
                 </a:solidFill>
-                <a:latin typeface="Arial"/>
-              </a:rPr>
-              <a:t>Hallazgos y valor estratégico</a:t>
-            </a:r>
-          </a:p>
-        </p:txBody>
-      </p:sp>
-      <p:sp>
-        <p:nvSpPr>
-          <p:cNvPr id="5" name="TextBox 4"/>
-          <p:cNvSpPr txBox="1"/>
-          <p:nvPr/>
-        </p:nvSpPr>
-        <p:spPr>
-          <a:xfrm>
-            <a:off x="548640" y="1783080"/>
-            <a:ext cx="5943600" cy="4480560"/>
-          </a:xfrm>
-          <a:prstGeom prst="rect">
-            <a:avLst/>
-          </a:prstGeom>
-          <a:noFill/>
-        </p:spPr>
-        <p:txBody>
-          <a:bodyPr wrap="square" lIns="45720" rIns="45720" tIns="18288" bIns="18288">
-            <a:spAutoFit/>
-          </a:bodyPr>
-          <a:lstStyle/>
-          <a:p>
-            <a:pPr algn="l">
-              <a:spcBef>
-                <a:spcPts val="0"/>
-              </a:spcBef>
-              <a:spcAft>
-                <a:spcPts val="800"/>
-              </a:spcAft>
-            </a:pPr>
-            <a:r>
-              <a:rPr sz="1500" b="1" i="0">
-                <a:solidFill>
-                  <a:srgbClr val="E6FF00"/>
-                </a:solidFill>
-                <a:latin typeface="Arial"/>
-              </a:rPr>
-              <a:t>Principales hallazgos</a:t>
+                <a:latin typeface="Calibri"/>
+              </a:rPr>
+              <a:t>—  El perfil explica ~27% del sueldo: experiencia y liderazgo mandan.</a:t>
             </a:r>
           </a:p>
           <a:p>
@@ -9571,7 +9232,7 @@
                 </a:solidFill>
                 <a:latin typeface="Calibri"/>
               </a:rPr>
-              <a:t>—  El perfil explica ~30% del sueldo: experiencia y liderazgo mandan.</a:t>
+              <a:t>—  Dolarizarse no dio más premium ni estabilidad.</a:t>
             </a:r>
           </a:p>
           <a:p>
@@ -9590,7 +9251,7 @@
                 </a:solidFill>
                 <a:latin typeface="Calibri"/>
               </a:rPr>
-              <a:t>—  Poder de compra real estancado pese a nominales 10× mayores.</a:t>
+              <a:t>—  CABA, grandes empresas y backend (Go/Rust) concentran lo mejor.</a:t>
             </a:r>
           </a:p>
           <a:p>
@@ -9609,26 +9270,7 @@
                 </a:solidFill>
                 <a:latin typeface="Calibri"/>
               </a:rPr>
-              <a:t>—  Dolarizarse no dio más premium ni estabilidad.</a:t>
-            </a:r>
-          </a:p>
-          <a:p>
-            <a:pPr algn="l">
-              <a:spcBef>
-                <a:spcPts val="0"/>
-              </a:spcBef>
-              <a:spcAft>
-                <a:spcPts val="1000"/>
-              </a:spcAft>
-            </a:pPr>
-            <a:r>
-              <a:rPr sz="1350" b="0" i="0">
-                <a:solidFill>
-                  <a:srgbClr val="FFFFFF"/>
-                </a:solidFill>
-                <a:latin typeface="Calibri"/>
-              </a:rPr>
-              <a:t>—  CABA, grandes empresas y backend (Go/Rust) concentran lo mejor.</a:t>
+              <a:t>—  Pipeline 100% reproducible: fuentes crudas versionadas en parquet.</a:t>
             </a:r>
           </a:p>
         </p:txBody>
@@ -10146,7 +9788,7 @@
                 </a:solidFill>
                 <a:latin typeface="Calibri"/>
               </a:rPr>
-              <a:t>El sueldo real de un profesional tech está determinado por su perfil (rol, experiencia, tecnologías) y su contexto (provincia, modalidad), una vez ajustado por el contexto macroeconómico (inflación, tipo de cambio real, competitividad).</a:t>
+              <a:t>El sueldo real de un profesional tech está determinado por su perfil (rol, experiencia) y su contexto (provincia, modalidad, tamaño de empresa), una vez expresado en moneda constante para que las ediciones sean comparables entre sí.</a:t>
             </a:r>
           </a:p>
         </p:txBody>
@@ -10298,7 +9940,7 @@
                 </a:solidFill>
                 <a:latin typeface="Arial"/>
               </a:rPr>
-              <a:t>Siete hipótesis desagregadas</a:t>
+              <a:t>Seis hipótesis desagregadas</a:t>
             </a:r>
           </a:p>
         </p:txBody>
@@ -10311,7 +9953,7 @@
         </p:nvSpPr>
         <p:spPr>
           <a:xfrm>
-            <a:off x="548640" y="1828800"/>
+            <a:off x="548640" y="1965960"/>
             <a:ext cx="868680" cy="841248"/>
           </a:xfrm>
           <a:prstGeom prst="rect">
@@ -10355,7 +9997,7 @@
         </p:nvSpPr>
         <p:spPr>
           <a:xfrm>
-            <a:off x="548640" y="1993392"/>
+            <a:off x="548640" y="2130552"/>
             <a:ext cx="868680" cy="640080"/>
           </a:xfrm>
           <a:prstGeom prst="rect">
@@ -10397,7 +10039,7 @@
         </p:nvSpPr>
         <p:spPr>
           <a:xfrm>
-            <a:off x="1600200" y="2029968"/>
+            <a:off x="1600200" y="2167128"/>
             <a:ext cx="4206240" cy="640080"/>
           </a:xfrm>
           <a:prstGeom prst="rect">
@@ -10439,7 +10081,7 @@
         </p:nvSpPr>
         <p:spPr>
           <a:xfrm>
-            <a:off x="548640" y="2880360"/>
+            <a:off x="548640" y="3337560"/>
             <a:ext cx="868680" cy="841248"/>
           </a:xfrm>
           <a:prstGeom prst="rect">
@@ -10483,7 +10125,7 @@
         </p:nvSpPr>
         <p:spPr>
           <a:xfrm>
-            <a:off x="548640" y="3044952"/>
+            <a:off x="548640" y="3502152"/>
             <a:ext cx="868680" cy="640080"/>
           </a:xfrm>
           <a:prstGeom prst="rect">
@@ -10525,7 +10167,7 @@
         </p:nvSpPr>
         <p:spPr>
           <a:xfrm>
-            <a:off x="1600200" y="3081528"/>
+            <a:off x="1600200" y="3538728"/>
             <a:ext cx="4206240" cy="640080"/>
           </a:xfrm>
           <a:prstGeom prst="rect">
@@ -10567,7 +10209,7 @@
         </p:nvSpPr>
         <p:spPr>
           <a:xfrm>
-            <a:off x="548640" y="3931920"/>
+            <a:off x="548640" y="4709160"/>
             <a:ext cx="868680" cy="841248"/>
           </a:xfrm>
           <a:prstGeom prst="rect">
@@ -10611,7 +10253,7 @@
         </p:nvSpPr>
         <p:spPr>
           <a:xfrm>
-            <a:off x="548640" y="4096511"/>
+            <a:off x="548640" y="4873752"/>
             <a:ext cx="868680" cy="640080"/>
           </a:xfrm>
           <a:prstGeom prst="rect">
@@ -10653,7 +10295,7 @@
         </p:nvSpPr>
         <p:spPr>
           <a:xfrm>
-            <a:off x="1600200" y="4133087"/>
+            <a:off x="1600200" y="4910328"/>
             <a:ext cx="4206240" cy="640080"/>
           </a:xfrm>
           <a:prstGeom prst="rect">
@@ -10695,7 +10337,7 @@
         </p:nvSpPr>
         <p:spPr>
           <a:xfrm>
-            <a:off x="548640" y="4983479"/>
+            <a:off x="6309360" y="1965960"/>
             <a:ext cx="868680" cy="841248"/>
           </a:xfrm>
           <a:prstGeom prst="rect">
@@ -10739,7 +10381,7 @@
         </p:nvSpPr>
         <p:spPr>
           <a:xfrm>
-            <a:off x="548640" y="5148071"/>
+            <a:off x="6309360" y="2130552"/>
             <a:ext cx="868680" cy="640080"/>
           </a:xfrm>
           <a:prstGeom prst="rect">
@@ -10781,7 +10423,7 @@
         </p:nvSpPr>
         <p:spPr>
           <a:xfrm>
-            <a:off x="1600200" y="5184647"/>
+            <a:off x="7360920" y="2167128"/>
             <a:ext cx="4206240" cy="640080"/>
           </a:xfrm>
           <a:prstGeom prst="rect">
@@ -10823,7 +10465,7 @@
         </p:nvSpPr>
         <p:spPr>
           <a:xfrm>
-            <a:off x="6309360" y="1828800"/>
+            <a:off x="6309360" y="3337560"/>
             <a:ext cx="868680" cy="841248"/>
           </a:xfrm>
           <a:prstGeom prst="rect">
@@ -10867,7 +10509,7 @@
         </p:nvSpPr>
         <p:spPr>
           <a:xfrm>
-            <a:off x="6309360" y="1993392"/>
+            <a:off x="6309360" y="3502152"/>
             <a:ext cx="868680" cy="640080"/>
           </a:xfrm>
           <a:prstGeom prst="rect">
@@ -10909,7 +10551,7 @@
         </p:nvSpPr>
         <p:spPr>
           <a:xfrm>
-            <a:off x="7360920" y="2029968"/>
+            <a:off x="7360920" y="3538728"/>
             <a:ext cx="4206240" cy="640080"/>
           </a:xfrm>
           <a:prstGeom prst="rect">
@@ -10938,7 +10580,7 @@
                 </a:solidFill>
                 <a:latin typeface="Calibri"/>
               </a:rPr>
-              <a:t>Nominal ≠ poder adquisitivo real</a:t>
+              <a:t>Cobrar en dólares da más estabilidad</a:t>
             </a:r>
           </a:p>
         </p:txBody>
@@ -10951,7 +10593,7 @@
         </p:nvSpPr>
         <p:spPr>
           <a:xfrm>
-            <a:off x="6309360" y="2880360"/>
+            <a:off x="6309360" y="4709160"/>
             <a:ext cx="868680" cy="841248"/>
           </a:xfrm>
           <a:prstGeom prst="rect">
@@ -10995,7 +10637,7 @@
         </p:nvSpPr>
         <p:spPr>
           <a:xfrm>
-            <a:off x="6309360" y="3044952"/>
+            <a:off x="6309360" y="4873752"/>
             <a:ext cx="868680" cy="640080"/>
           </a:xfrm>
           <a:prstGeom prst="rect">
@@ -11037,135 +10679,7 @@
         </p:nvSpPr>
         <p:spPr>
           <a:xfrm>
-            <a:off x="7360920" y="3081528"/>
-            <a:ext cx="4206240" cy="640080"/>
-          </a:xfrm>
-          <a:prstGeom prst="rect">
-            <a:avLst/>
-          </a:prstGeom>
-          <a:noFill/>
-        </p:spPr>
-        <p:txBody>
-          <a:bodyPr wrap="square" lIns="45720" rIns="45720" tIns="18288" bIns="18288">
-            <a:spAutoFit/>
-          </a:bodyPr>
-          <a:lstStyle/>
-          <a:p>
-            <a:pPr algn="l">
-              <a:spcBef>
-                <a:spcPts val="0"/>
-              </a:spcBef>
-              <a:spcAft>
-                <a:spcPts val="0"/>
-              </a:spcAft>
-            </a:pPr>
-            <a:r>
-              <a:rPr sz="1400" b="0" i="0">
-                <a:solidFill>
-                  <a:srgbClr val="FFFFFF"/>
-                </a:solidFill>
-                <a:latin typeface="Calibri"/>
-              </a:rPr>
-              <a:t>Cobrar en dólares da más estabilidad</a:t>
-            </a:r>
-          </a:p>
-        </p:txBody>
-      </p:sp>
-      <p:sp>
-        <p:nvSpPr>
-          <p:cNvPr id="23" name="Rectangle 22"/>
-          <p:cNvSpPr/>
-          <p:nvPr/>
-        </p:nvSpPr>
-        <p:spPr>
-          <a:xfrm>
-            <a:off x="6309360" y="3931920"/>
-            <a:ext cx="868680" cy="841248"/>
-          </a:xfrm>
-          <a:prstGeom prst="rect">
-            <a:avLst/>
-          </a:prstGeom>
-          <a:solidFill>
-            <a:srgbClr val="E6FF00"/>
-          </a:solidFill>
-          <a:ln>
-            <a:noFill/>
-          </a:ln>
-          <a:effectLst/>
-        </p:spPr>
-        <p:style>
-          <a:lnRef idx="1">
-            <a:schemeClr val="accent1"/>
-          </a:lnRef>
-          <a:fillRef idx="3">
-            <a:schemeClr val="accent1"/>
-          </a:fillRef>
-          <a:effectRef idx="2">
-            <a:schemeClr val="accent1"/>
-          </a:effectRef>
-          <a:fontRef idx="minor">
-            <a:schemeClr val="lt1"/>
-          </a:fontRef>
-        </p:style>
-        <p:txBody>
-          <a:bodyPr rtlCol="0" anchor="ctr"/>
-          <a:lstStyle/>
-          <a:p>
-            <a:pPr algn="ctr"/>
-          </a:p>
-        </p:txBody>
-      </p:sp>
-      <p:sp>
-        <p:nvSpPr>
-          <p:cNvPr id="24" name="TextBox 23"/>
-          <p:cNvSpPr txBox="1"/>
-          <p:nvPr/>
-        </p:nvSpPr>
-        <p:spPr>
-          <a:xfrm>
-            <a:off x="6309360" y="4096511"/>
-            <a:ext cx="868680" cy="640080"/>
-          </a:xfrm>
-          <a:prstGeom prst="rect">
-            <a:avLst/>
-          </a:prstGeom>
-          <a:noFill/>
-        </p:spPr>
-        <p:txBody>
-          <a:bodyPr wrap="square" lIns="45720" rIns="45720" tIns="18288" bIns="18288">
-            <a:spAutoFit/>
-          </a:bodyPr>
-          <a:lstStyle/>
-          <a:p>
-            <a:pPr algn="ctr">
-              <a:spcBef>
-                <a:spcPts val="0"/>
-              </a:spcBef>
-              <a:spcAft>
-                <a:spcPts val="0"/>
-              </a:spcAft>
-            </a:pPr>
-            <a:r>
-              <a:rPr sz="2200" b="1" i="0">
-                <a:solidFill>
-                  <a:srgbClr val="0A0A0A"/>
-                </a:solidFill>
-                <a:latin typeface="Arial"/>
-              </a:rPr>
-              <a:t>H7</a:t>
-            </a:r>
-          </a:p>
-        </p:txBody>
-      </p:sp>
-      <p:sp>
-        <p:nvSpPr>
-          <p:cNvPr id="25" name="TextBox 24"/>
-          <p:cNvSpPr txBox="1"/>
-          <p:nvPr/>
-        </p:nvSpPr>
-        <p:spPr>
-          <a:xfrm>
-            <a:off x="7360920" y="4133087"/>
+            <a:off x="7360920" y="4910328"/>
             <a:ext cx="4206240" cy="640080"/>
           </a:xfrm>
           <a:prstGeom prst="rect">

</xml_diff>